<commit_message>
sd-12-001..005: answer review (program shown in lesson, Gmail wording, MDA role, alt text, honest mobile status)
Co-Authored-By: Claude Sonnet 5.5 <noreply@anthropic.com>
Claude-Session: https://claude.ai/code/session_01YWnTQqPDLSbUsxkfwNWsvG
</commit_message>
<xml_diff>
--- a/system-design-101/vi/lessons/sd-12-003/slides/sd-12-003.pptx
+++ b/system-design-101/vi/lessons/sd-12-003/slides/sd-12-003.pptx
@@ -10096,7 +10096,7 @@
               <a:t>Bob</a:t>
             </a:r>
             <a:r>
-              <a:rPr lang="en-US" sz="6900" dirty="0" spc="-1" kern="0">
+              <a:rPr lang="en-US" sz="6900" dirty="0" spc="11" kern="0">
                 <a:solidFill>
                   <a:srgbClr val="14161C"/>
                 </a:solidFill>
@@ -10104,10 +10104,10 @@
                 <a:ea typeface="Bricolage Grotesque ExtraBold" pitchFamily="34" charset="-122"/>
                 <a:cs typeface="Bricolage Grotesque ExtraBold" pitchFamily="34" charset="-120"/>
               </a:rPr>
-              <a:t> mở</a:t>
-            </a:r>
-            <a:r>
-              <a:rPr lang="en-US" sz="6900" dirty="0" spc="-2" kern="0">
+              <a:t> đọc</a:t>
+            </a:r>
+            <a:r>
+              <a:rPr lang="en-US" sz="6900" dirty="0" spc="-41" kern="0">
                 <a:solidFill>
                   <a:srgbClr val="14161C"/>
                 </a:solidFill>
@@ -10115,10 +10115,10 @@
                 <a:ea typeface="Bricolage Grotesque ExtraBold" pitchFamily="34" charset="-122"/>
                 <a:cs typeface="Bricolage Grotesque ExtraBold" pitchFamily="34" charset="-120"/>
               </a:rPr>
-              <a:t> Gmail,</a:t>
-            </a:r>
-            <a:r>
-              <a:rPr lang="en-US" sz="6900" dirty="0" spc="1" kern="0">
+              <a:t> thư,</a:t>
+            </a:r>
+            <a:r>
+              <a:rPr lang="en-US" sz="6900" dirty="0" spc="0" kern="0">
                 <a:solidFill>
                   <a:srgbClr val="14161C"/>
                 </a:solidFill>
@@ -10276,6 +10276,17 @@
               <a:t> mở</a:t>
             </a:r>
             <a:r>
+              <a:rPr lang="en-US" sz="2850" b="1" dirty="0" spc="-8" kern="0">
+                <a:solidFill>
+                  <a:srgbClr val="14161C"/>
+                </a:solidFill>
+                <a:latin typeface="Be Vietnam Pro" pitchFamily="34" charset="0"/>
+                <a:ea typeface="Be Vietnam Pro" pitchFamily="34" charset="-122"/>
+                <a:cs typeface="Be Vietnam Pro" pitchFamily="34" charset="-120"/>
+              </a:rPr>
+              <a:t> hộp</a:t>
+            </a:r>
+            <a:r>
               <a:rPr lang="en-US" sz="2850" b="1" dirty="0" spc="0" kern="0">
                 <a:solidFill>
                   <a:srgbClr val="14161C"/>
@@ -10284,10 +10295,10 @@
                 <a:ea typeface="Be Vietnam Pro" pitchFamily="34" charset="-122"/>
                 <a:cs typeface="Be Vietnam Pro" pitchFamily="34" charset="-120"/>
               </a:rPr>
-              <a:t> Gmail,</a:t>
-            </a:r>
-            <a:r>
-              <a:rPr lang="en-US" sz="2850" b="1" dirty="0" spc="6" kern="0">
+              <a:t> thư</a:t>
+            </a:r>
+            <a:r>
+              <a:rPr lang="en-US" sz="2850" b="1" dirty="0" spc="3" kern="0">
                 <a:solidFill>
                   <a:srgbClr val="14161C"/>
                 </a:solidFill>
@@ -10295,7 +10306,7 @@
                 <a:ea typeface="Be Vietnam Pro" pitchFamily="34" charset="-122"/>
                 <a:cs typeface="Be Vietnam Pro" pitchFamily="34" charset="-120"/>
               </a:rPr>
-              <a:t> đăng</a:t>
+              <a:t> của</a:t>
             </a:r>
             <a:r>
               <a:rPr lang="en-US" sz="2850" b="1" dirty="0" spc="1" kern="0">
@@ -10306,7 +10317,7 @@
                 <a:ea typeface="Be Vietnam Pro" pitchFamily="34" charset="-122"/>
                 <a:cs typeface="Be Vietnam Pro" pitchFamily="34" charset="-120"/>
               </a:rPr>
-              <a:t> nhập</a:t>
+              <a:t> mình</a:t>
             </a:r>
             <a:endParaRPr lang="en-US" sz="2850" dirty="0"/>
           </a:p>
@@ -10436,10 +10447,10 @@
                 <a:ea typeface="Be Vietnam Pro" pitchFamily="34" charset="-122"/>
                 <a:cs typeface="Be Vietnam Pro" pitchFamily="34" charset="-120"/>
               </a:rPr>
-              <a:t> dụng</a:t>
-            </a:r>
-            <a:r>
-              <a:rPr lang="en-US" sz="2850" b="1" dirty="0" spc="-12" kern="0">
+              <a:t> dụng thư</a:t>
+            </a:r>
+            <a:r>
+              <a:rPr lang="en-US" sz="2850" b="1" dirty="0" spc="3" kern="0">
                 <a:solidFill>
                   <a:srgbClr val="14161C"/>
                 </a:solidFill>
@@ -10447,6 +10458,17 @@
                 <a:ea typeface="Be Vietnam Pro" pitchFamily="34" charset="-122"/>
                 <a:cs typeface="Be Vietnam Pro" pitchFamily="34" charset="-120"/>
               </a:rPr>
+              <a:t> riêng</a:t>
+            </a:r>
+            <a:r>
+              <a:rPr lang="en-US" sz="2850" b="1" dirty="0" spc="-11" kern="0">
+                <a:solidFill>
+                  <a:srgbClr val="14161C"/>
+                </a:solidFill>
+                <a:latin typeface="Be Vietnam Pro" pitchFamily="34" charset="0"/>
+                <a:ea typeface="Be Vietnam Pro" pitchFamily="34" charset="-122"/>
+                <a:cs typeface="Be Vietnam Pro" pitchFamily="34" charset="-120"/>
+              </a:rPr>
               <a:t> lấy</a:t>
             </a:r>
             <a:r>
@@ -10472,7 +10494,7 @@
               <a:t> mới</a:t>
             </a:r>
             <a:r>
-              <a:rPr lang="en-US" sz="2850" b="1" dirty="0" spc="-21" kern="0">
+              <a:rPr lang="en-US" sz="2850" b="1" dirty="0" spc="-22" kern="0">
                 <a:solidFill>
                   <a:srgbClr val="14161C"/>
                 </a:solidFill>

</xml_diff>

<commit_message>
sd-12-003, sd-12-005: qualify Outlook submission, state the 100-point bound, label query statistics, drop one-pass claim
Co-Authored-By: Claude Sonnet 5.5 <noreply@anthropic.com>
Claude-Session: https://claude.ai/code/session_01YWnTQqPDLSbUsxkfwNWsvG
</commit_message>
<xml_diff>
--- a/system-design-101/vi/lessons/sd-12-003/slides/sd-12-003.pptx
+++ b/system-design-101/vi/lessons/sd-12-003/slides/sd-12-003.pptx
@@ -6729,10 +6729,10 @@
                 <a:ea typeface="Be Vietnam Pro" pitchFamily="34" charset="-122"/>
                 <a:cs typeface="Be Vietnam Pro" pitchFamily="34" charset="-120"/>
               </a:rPr>
-              <a:t> thư</a:t>
-            </a:r>
-            <a:r>
-              <a:rPr lang="en-US" sz="2700" b="1" dirty="0" spc="-3" kern="0">
+              <a:t> thư, ở</a:t>
+            </a:r>
+            <a:r>
+              <a:rPr lang="en-US" sz="2700" b="1" dirty="0" spc="-4" kern="0">
                 <a:solidFill>
                   <a:srgbClr val="14161C"/>
                 </a:solidFill>
@@ -6740,7 +6740,18 @@
                 <a:ea typeface="Be Vietnam Pro" pitchFamily="34" charset="-122"/>
                 <a:cs typeface="Be Vietnam Pro" pitchFamily="34" charset="-120"/>
               </a:rPr>
-              <a:t> bằng</a:t>
+              <a:t> đây</a:t>
+            </a:r>
+            <a:r>
+              <a:rPr lang="en-US" sz="2700" b="1" dirty="0" spc="0" kern="0">
+                <a:solidFill>
+                  <a:srgbClr val="14161C"/>
+                </a:solidFill>
+                <a:latin typeface="Be Vietnam Pro" pitchFamily="34" charset="0"/>
+                <a:ea typeface="Be Vietnam Pro" pitchFamily="34" charset="-122"/>
+                <a:cs typeface="Be Vietnam Pro" pitchFamily="34" charset="-120"/>
+              </a:rPr>
+              <a:t> qua</a:t>
             </a:r>
             <a:r>
               <a:rPr lang="en-US" sz="2700" b="1" dirty="0" spc="-2" kern="0">
@@ -12902,7 +12913,7 @@
               <a:buNone/>
             </a:pPr>
             <a:r>
-              <a:rPr lang="en-US" sz="2700" b="1" dirty="0" spc="-55" kern="0">
+              <a:rPr lang="en-US" sz="2700" b="1" dirty="0" spc="-3" kern="0">
                 <a:solidFill>
                   <a:srgbClr val="F3EEE3"/>
                 </a:solidFill>
@@ -12910,10 +12921,10 @@
                 <a:ea typeface="Be Vietnam Pro" pitchFamily="34" charset="-122"/>
                 <a:cs typeface="Be Vietnam Pro" pitchFamily="34" charset="-120"/>
               </a:rPr>
-              <a:t>Web</a:t>
-            </a:r>
-            <a:r>
-              <a:rPr lang="en-US" sz="2700" b="1" dirty="0" spc="-3" kern="0">
+              <a:t>Gmail</a:t>
+            </a:r>
+            <a:r>
+              <a:rPr lang="en-US" sz="2700" b="1" dirty="0" spc="-17" kern="0">
                 <a:solidFill>
                   <a:srgbClr val="F3EEE3"/>
                 </a:solidFill>
@@ -12921,7 +12932,7 @@
                 <a:ea typeface="Be Vietnam Pro" pitchFamily="34" charset="-122"/>
                 <a:cs typeface="Be Vietnam Pro" pitchFamily="34" charset="-120"/>
               </a:rPr>
-              <a:t> Gmail</a:t>
+              <a:t> web,</a:t>
             </a:r>
             <a:r>
               <a:rPr lang="en-US" sz="2700" b="1" dirty="0" spc="-6" kern="0">
@@ -12932,10 +12943,32 @@
                 <a:ea typeface="Be Vietnam Pro" pitchFamily="34" charset="-122"/>
                 <a:cs typeface="Be Vietnam Pro" pitchFamily="34" charset="-120"/>
               </a:rPr>
+              <a:t> Outlook</a:t>
+            </a:r>
+            <a:r>
+              <a:rPr lang="en-US" sz="2700" b="1" dirty="0" spc="1" kern="0">
+                <a:solidFill>
+                  <a:srgbClr val="F3EEE3"/>
+                </a:solidFill>
+                <a:latin typeface="Be Vietnam Pro" pitchFamily="34" charset="0"/>
+                <a:ea typeface="Be Vietnam Pro" pitchFamily="34" charset="-122"/>
+                <a:cs typeface="Be Vietnam Pro" pitchFamily="34" charset="-120"/>
+              </a:rPr>
+              <a:t> mới:</a:t>
+            </a:r>
+            <a:r>
+              <a:rPr lang="en-US" sz="2700" b="1" dirty="0" spc="-6" kern="0">
+                <a:solidFill>
+                  <a:srgbClr val="F3EEE3"/>
+                </a:solidFill>
+                <a:latin typeface="Be Vietnam Pro" pitchFamily="34" charset="0"/>
+                <a:ea typeface="Be Vietnam Pro" pitchFamily="34" charset="-122"/>
+                <a:cs typeface="Be Vietnam Pro" pitchFamily="34" charset="-120"/>
+              </a:rPr>
               <a:t> không</a:t>
             </a:r>
             <a:r>
-              <a:rPr lang="en-US" sz="2700" b="1" dirty="0" spc="-8" kern="0">
+              <a:rPr lang="en-US" sz="2700" b="1" dirty="0" spc="-7" kern="0">
                 <a:solidFill>
                   <a:srgbClr val="F3EEE3"/>
                 </a:solidFill>
@@ -12946,7 +12979,7 @@
               <a:t> nhất</a:t>
             </a:r>
             <a:r>
-              <a:rPr lang="en-US" sz="2700" b="1" dirty="0" spc="-5" kern="0">
+              <a:rPr lang="en-US" sz="2700" b="1" dirty="0" spc="-6" kern="0">
                 <a:solidFill>
                   <a:srgbClr val="F3EEE3"/>
                 </a:solidFill>
@@ -12965,10 +12998,10 @@
                 <a:ea typeface="Be Vietnam Pro" pitchFamily="34" charset="-122"/>
                 <a:cs typeface="Be Vietnam Pro" pitchFamily="34" charset="-120"/>
               </a:rPr>
-              <a:t> dùng</a:t>
-            </a:r>
-            <a:r>
-              <a:rPr lang="en-US" sz="2700" b="1" dirty="0" spc="-3" kern="0">
+              <a:t> SMTP, IMAP</a:t>
+            </a:r>
+            <a:r>
+              <a:rPr lang="en-US" sz="2700" b="1" dirty="0" spc="-12" kern="0">
                 <a:solidFill>
                   <a:srgbClr val="F3EEE3"/>
                 </a:solidFill>
@@ -12976,21 +13009,10 @@
                 <a:ea typeface="Be Vietnam Pro" pitchFamily="34" charset="-122"/>
                 <a:cs typeface="Be Vietnam Pro" pitchFamily="34" charset="-120"/>
               </a:rPr>
-              <a:t> IMAP</a:t>
-            </a:r>
-            <a:r>
-              <a:rPr lang="en-US" sz="2700" b="1" dirty="0" spc="-12" kern="0">
-                <a:solidFill>
-                  <a:srgbClr val="F3EEE3"/>
-                </a:solidFill>
-                <a:latin typeface="Be Vietnam Pro" pitchFamily="34" charset="0"/>
-                <a:ea typeface="Be Vietnam Pro" pitchFamily="34" charset="-122"/>
-                <a:cs typeface="Be Vietnam Pro" pitchFamily="34" charset="-120"/>
-              </a:rPr>
               <a:t> hay</a:t>
             </a:r>
             <a:r>
-              <a:rPr lang="en-US" sz="2700" b="1" dirty="0" spc="-3" kern="0">
+              <a:rPr lang="en-US" sz="2700" b="1" dirty="0" spc="-4" kern="0">
                 <a:solidFill>
                   <a:srgbClr val="F3EEE3"/>
                 </a:solidFill>

</xml_diff>